<commit_message>
docs: actualizar el conteo final de commits en el informe y la presentación
Co-Authored-By: Claude Opus 5.5 <noreply@anthropic.com>
Claude-Session: https://claude.ai/code/session_019yAiQ6SJ8faHeryAa6w9Vi
</commit_message>
<xml_diff>
--- a/Fase 2/Evidencias Grupales/Presentacion Proyecto.pptx
+++ b/Fase 2/Evidencias Grupales/Presentacion Proyecto.pptx
@@ -117,19 +117,19 @@
   <p:extLst>
     <p:ext uri="{521415D9-36F7-43E2-AB2F-B90AF26B5E84}">
       <p14:sectionLst xmlns:p14="http://schemas.microsoft.com/office/powerpoint/2010/main">
-        <p14:section name="Apertura" id="{a70a8f83-7835-7923-8d7a-f47de41aa94c}">
+        <p14:section name="Apertura" id="{866ddaff-aa1b-dbb8-5e7e-4d62d571214e}">
           <p14:sldIdLst>
             <p14:sldId id="256"/>
             <p14:sldId id="257"/>
           </p14:sldIdLst>
         </p14:section>
-        <p14:section name="Problema y producto" id="{f985e1cb-539b-993f-4878-fafca7ccc956}">
+        <p14:section name="Problema y producto" id="{29b7c8e0-4e5e-750a-9eb8-d4953cb6a473}">
           <p14:sldIdLst>
             <p14:sldId id="258"/>
             <p14:sldId id="259"/>
           </p14:sldIdLst>
         </p14:section>
-        <p14:section name="Metodología y avance" id="{b7cf43bf-7d51-ef86-4a32-a020268c0345}">
+        <p14:section name="Metodología y avance" id="{f568709b-3c1d-dcdc-beb9-3cdc9b1de3a7}">
           <p14:sldIdLst>
             <p14:sldId id="260"/>
             <p14:sldId id="261"/>
@@ -137,13 +137,13 @@
             <p14:sldId id="263"/>
           </p14:sldIdLst>
         </p14:section>
-        <p14:section name="Perfil y proyección" id="{cbaea018-943f-793f-8da9-6f2778f03ab9}">
+        <p14:section name="Perfil y proyección" id="{044dc383-3ea9-fca5-23ee-5efac6e96110}">
           <p14:sldIdLst>
             <p14:sldId id="264"/>
             <p14:sldId id="265"/>
           </p14:sldIdLst>
         </p14:section>
-        <p14:section name="Cierre" id="{1301fd83-f090-8d30-4ce3-dd921bbb7a06}">
+        <p14:section name="Cierre" id="{361bf3c2-ed62-9d39-2ac2-08854baaf1f2}">
           <p14:sldIdLst>
             <p14:sldId id="266"/>
           </p14:sldIdLst>
@@ -1267,7 +1267,7 @@
             <a:r>
               <a:rPr lang="en-US" dirty="0"/>
               <a:t>Presenta: Joaquín (40 segundos).
-En cifras: terminamos 8 de las 28 historias del backlog, que equivalen a 24 de los 100 puntos de función. El modelo de datos está implementado completo, con 14 tablas creadas mediante migraciones versionadas. Tenemos 29 pruebas automatizadas, que verifican las reglas de negocio, los permisos por rol y las migraciones. Y el historial del repositorio registra 48 commits con la autoría de cada integrante, 29 de Joaquín y 19 de Gonzalo.</a:t>
+En cifras: terminamos 8 de las 28 historias del backlog, que equivalen a 24 de los 100 puntos de función. El modelo de datos está implementado completo, con 14 tablas creadas mediante migraciones versionadas. Tenemos 29 pruebas automatizadas, que verifican las reglas de negocio, los permisos por rol y las migraciones. Y el historial del repositorio registra 51 commits con la autoría de cada integrante, 30 de Joaquín y 21 de Gonzalo.</a:t>
             </a:r>
             <a:endParaRPr lang="en-US" dirty="0"/>
           </a:p>
@@ -9647,7 +9647,7 @@
                 <a:ea typeface="Cambria" pitchFamily="34" charset="-122"/>
                 <a:cs typeface="Cambria" pitchFamily="34" charset="-120"/>
               </a:rPr>
-              <a:t>48</a:t>
+              <a:t>51</a:t>
             </a:r>
             <a:endParaRPr lang="en-US" sz="5400" dirty="0"/>
           </a:p>
@@ -9719,7 +9719,7 @@
                   <a:schemeClr val="accent4"/>
                 </a:solidFill>
               </a:rPr>
-              <a:t>29 de Joaquín y 19 de Gonzalo</a:t>
+              <a:t>30 de Joaquín y 21 de Gonzalo</a:t>
             </a:r>
             <a:endParaRPr lang="en-US" sz="1200" dirty="0"/>
           </a:p>

</xml_diff>

<commit_message>
docs: describir en el informe y la presentación el aplazamiento de las reuniones
Co-Authored-By: Claude Opus 5.5 <noreply@anthropic.com>
Claude-Session: https://claude.ai/code/session_019yAiQ6SJ8faHeryAa6w9Vi
</commit_message>
<xml_diff>
--- a/Fase 2/Evidencias Grupales/Presentacion Proyecto.pptx
+++ b/Fase 2/Evidencias Grupales/Presentacion Proyecto.pptx
@@ -117,19 +117,19 @@
   <p:extLst>
     <p:ext uri="{521415D9-36F7-43E2-AB2F-B90AF26B5E84}">
       <p14:sectionLst xmlns:p14="http://schemas.microsoft.com/office/powerpoint/2010/main">
-        <p14:section name="Apertura" id="{866ddaff-aa1b-dbb8-5e7e-4d62d571214e}">
+        <p14:section name="Apertura" id="{f3db45a8-9ae8-bcfc-efeb-ad5906308446}">
           <p14:sldIdLst>
             <p14:sldId id="256"/>
             <p14:sldId id="257"/>
           </p14:sldIdLst>
         </p14:section>
-        <p14:section name="Problema y producto" id="{29b7c8e0-4e5e-750a-9eb8-d4953cb6a473}">
+        <p14:section name="Problema y producto" id="{d6481558-cabc-209f-cd64-87c66fff2017}">
           <p14:sldIdLst>
             <p14:sldId id="258"/>
             <p14:sldId id="259"/>
           </p14:sldIdLst>
         </p14:section>
-        <p14:section name="Metodología y avance" id="{f568709b-3c1d-dcdc-beb9-3cdc9b1de3a7}">
+        <p14:section name="Metodología y avance" id="{192b3a3b-b41c-7c3a-699e-f03b7d426d00}">
           <p14:sldIdLst>
             <p14:sldId id="260"/>
             <p14:sldId id="261"/>
@@ -137,13 +137,13 @@
             <p14:sldId id="263"/>
           </p14:sldIdLst>
         </p14:section>
-        <p14:section name="Perfil y proyección" id="{044dc383-3ea9-fca5-23ee-5efac6e96110}">
+        <p14:section name="Perfil y proyección" id="{11af7064-1348-7ece-43b9-6cdde80aebe8}">
           <p14:sldIdLst>
             <p14:sldId id="264"/>
             <p14:sldId id="265"/>
           </p14:sldIdLst>
         </p14:section>
-        <p14:section name="Cierre" id="{361bf3c2-ed62-9d39-2ac2-08854baaf1f2}">
+        <p14:section name="Cierre" id="{7a5a5120-aa4f-0ab3-2677-b2bfd58cc26e}">
           <p14:sldIdLst>
             <p14:sldId id="266"/>
           </p14:sldIdLst>
@@ -1267,7 +1267,7 @@
             <a:r>
               <a:rPr lang="en-US" dirty="0"/>
               <a:t>Presenta: Joaquín (40 segundos).
-En cifras: terminamos 8 de las 28 historias del backlog, que equivalen a 24 de los 100 puntos de función. El modelo de datos está implementado completo, con 14 tablas creadas mediante migraciones versionadas. Tenemos 29 pruebas automatizadas, que verifican las reglas de negocio, los permisos por rol y las migraciones. Y el historial del repositorio registra 51 commits con la autoría de cada integrante, 30 de Joaquín y 21 de Gonzalo.</a:t>
+En cifras: terminamos 8 de las 28 historias del backlog, que equivalen a 24 de los 100 puntos de función. El modelo de datos está implementado completo, con 14 tablas creadas mediante migraciones versionadas. Tenemos 29 pruebas automatizadas, que verifican las reglas de negocio, los permisos por rol y las migraciones. Y el historial del repositorio registra 55 commits con la autoría de cada integrante, 32 de Joaquín y 23 de Gonzalo.</a:t>
             </a:r>
             <a:endParaRPr lang="en-US" dirty="0"/>
           </a:p>
@@ -1356,7 +1356,7 @@
             <a:r>
               <a:rPr lang="en-US" dirty="0"/>
               <a:t>Presenta: Joaquín (45 segundos).
-Enfrentamos cuatro dificultades. La empresa no continuó la colaboración: consultamos al docente y seguimos con los supuestos del modelo declarados como decisiones de diseño. La más importante fue nuestra: el plan tenía rangos de semanas pero no hitos verificables, y eso permitió que el desarrollo se detuviera; lo corregimos con sprints, una definición de terminado y una rama por semana. También resolvimos el bloqueo del entorno. Y al probar las migraciones descubrimos que Flyway no se estaba ejecutando: lo corregimos y agregamos una prueba que lo verifica, que es exactamente para lo que sirven las pruebas.</a:t>
+Enfrentamos cuatro dificultades. Las reuniones de validación con la empresa se aplazaron y no podíamos seguir esperando: consultamos al docente, continuamos con la propuesta original y declaramos los supuestos del modelo como decisiones de diseño. La más importante fue nuestra: el plan tenía rangos de semanas pero no hitos verificables, y eso permitió que el desarrollo se detuviera; lo corregimos con sprints, una definición de terminado y una rama por semana. También resolvimos el bloqueo del entorno. Y al probar las migraciones descubrimos que Flyway no se estaba ejecutando: lo corregimos y agregamos una prueba que lo verifica, que es exactamente para lo que sirven las pruebas.</a:t>
             </a:r>
             <a:endParaRPr lang="en-US" dirty="0"/>
           </a:p>
@@ -9647,7 +9647,7 @@
                 <a:ea typeface="Cambria" pitchFamily="34" charset="-122"/>
                 <a:cs typeface="Cambria" pitchFamily="34" charset="-120"/>
               </a:rPr>
-              <a:t>51</a:t>
+              <a:t>55</a:t>
             </a:r>
             <a:endParaRPr lang="en-US" sz="5400" dirty="0"/>
           </a:p>
@@ -9719,7 +9719,7 @@
                   <a:schemeClr val="accent4"/>
                 </a:solidFill>
               </a:rPr>
-              <a:t>30 de Joaquín y 21 de Gonzalo</a:t>
+              <a:t>32 de Joaquín y 23 de Gonzalo</a:t>
             </a:r>
             <a:endParaRPr lang="en-US" sz="1200" dirty="0"/>
           </a:p>
@@ -10213,7 +10213,7 @@
                   <a:schemeClr val="tx2"/>
                 </a:solidFill>
               </a:rPr>
-              <a:t>La empresa no continuó la colaboración</a:t>
+              <a:t>Las reuniones con la empresa se aplazaron</a:t>
             </a:r>
             <a:endParaRPr lang="en-US" sz="1500" dirty="0"/>
           </a:p>
@@ -10312,7 +10312,7 @@
                   <a:schemeClr val="tx1"/>
                 </a:solidFill>
               </a:rPr>
-              <a:t>Con autorización del docente se continúa sin cliente real; los supuestos del modelo pasan a ser decisiones de diseño declaradas.</a:t>
+              <a:t>Para no detener el proyecto, se consultó al docente y se continuó con la propuesta original; los supuestos del modelo pasan a ser decisiones de diseño declaradas.</a:t>
             </a:r>
             <a:endParaRPr lang="en-US" sz="1300" dirty="0"/>
           </a:p>

</xml_diff>

<commit_message>
docs: actualizar el README con el flujo de ramas semanal y el estado del Sprint 2
Incluye el conteo final de commits en el informe 2.6 y la presentación.

Co-Authored-By: Claude Opus 5.5 <noreply@anthropic.com>
Claude-Session: https://claude.ai/code/session_019yAiQ6SJ8faHeryAa6w9Vi
</commit_message>
<xml_diff>
--- a/Fase 2/Evidencias Grupales/Presentacion Proyecto.pptx
+++ b/Fase 2/Evidencias Grupales/Presentacion Proyecto.pptx
@@ -117,19 +117,19 @@
   <p:extLst>
     <p:ext uri="{521415D9-36F7-43E2-AB2F-B90AF26B5E84}">
       <p14:sectionLst xmlns:p14="http://schemas.microsoft.com/office/powerpoint/2010/main">
-        <p14:section name="Apertura" id="{f3db45a8-9ae8-bcfc-efeb-ad5906308446}">
+        <p14:section name="Apertura" id="{ed7c7a13-3acd-9ebb-e78d-e5dfde30c218}">
           <p14:sldIdLst>
             <p14:sldId id="256"/>
             <p14:sldId id="257"/>
           </p14:sldIdLst>
         </p14:section>
-        <p14:section name="Problema y producto" id="{d6481558-cabc-209f-cd64-87c66fff2017}">
+        <p14:section name="Problema y producto" id="{d6f74cbe-19a2-d378-1fbf-1cc3f33496eb}">
           <p14:sldIdLst>
             <p14:sldId id="258"/>
             <p14:sldId id="259"/>
           </p14:sldIdLst>
         </p14:section>
-        <p14:section name="Metodología y avance" id="{192b3a3b-b41c-7c3a-699e-f03b7d426d00}">
+        <p14:section name="Metodología y avance" id="{4211bed7-232b-0bc8-295e-cda7999aacf1}">
           <p14:sldIdLst>
             <p14:sldId id="260"/>
             <p14:sldId id="261"/>
@@ -137,13 +137,13 @@
             <p14:sldId id="263"/>
           </p14:sldIdLst>
         </p14:section>
-        <p14:section name="Perfil y proyección" id="{11af7064-1348-7ece-43b9-6cdde80aebe8}">
+        <p14:section name="Perfil y proyección" id="{8f518df0-2576-cd6b-91bc-0ac3fff832c1}">
           <p14:sldIdLst>
             <p14:sldId id="264"/>
             <p14:sldId id="265"/>
           </p14:sldIdLst>
         </p14:section>
-        <p14:section name="Cierre" id="{7a5a5120-aa4f-0ab3-2677-b2bfd58cc26e}">
+        <p14:section name="Cierre" id="{556d0688-2354-2fca-ea8a-b24967f00d11}">
           <p14:sldIdLst>
             <p14:sldId id="266"/>
           </p14:sldIdLst>
@@ -1267,7 +1267,7 @@
             <a:r>
               <a:rPr lang="en-US" dirty="0"/>
               <a:t>Presenta: Joaquín (40 segundos).
-En cifras: terminamos 8 de las 28 historias del backlog, que equivalen a 24 de los 100 puntos de función. El modelo de datos está implementado completo, con 14 tablas creadas mediante migraciones versionadas. Tenemos 29 pruebas automatizadas, que verifican las reglas de negocio, los permisos por rol y las migraciones. Y el historial del repositorio registra 55 commits con la autoría de cada integrante, 32 de Joaquín y 23 de Gonzalo.</a:t>
+En cifras: terminamos 8 de las 28 historias del backlog, que equivalen a 24 de los 100 puntos de función. El modelo de datos está implementado completo, con 14 tablas creadas mediante migraciones versionadas. Tenemos 29 pruebas automatizadas, que verifican las reglas de negocio, los permisos por rol y las migraciones. Y el historial del repositorio registra 56 commits con la autoría de cada integrante, 32 de Joaquín y 24 de Gonzalo.</a:t>
             </a:r>
             <a:endParaRPr lang="en-US" dirty="0"/>
           </a:p>
@@ -9647,7 +9647,7 @@
                 <a:ea typeface="Cambria" pitchFamily="34" charset="-122"/>
                 <a:cs typeface="Cambria" pitchFamily="34" charset="-120"/>
               </a:rPr>
-              <a:t>55</a:t>
+              <a:t>56</a:t>
             </a:r>
             <a:endParaRPr lang="en-US" sz="5400" dirty="0"/>
           </a:p>
@@ -9719,7 +9719,7 @@
                   <a:schemeClr val="accent4"/>
                 </a:solidFill>
               </a:rPr>
-              <a:t>32 de Joaquín y 23 de Gonzalo</a:t>
+              <a:t>32 de Joaquín y 24 de Gonzalo</a:t>
             </a:r>
             <a:endParaRPr lang="en-US" sz="1200" dirty="0"/>
           </a:p>

</xml_diff>